<commit_message>
Updated Consultant feedback document basis the call
</commit_message>
<xml_diff>
--- a/_dev/Feedback/Consultant/19-Oct/10_19_2026_Update_For_Digital_Simulation.pptx
+++ b/_dev/Feedback/Consultant/19-Oct/10_19_2026_Update_For_Digital_Simulation.pptx
@@ -117,6 +117,11 @@
       </a:defRPr>
     </a:lvl9pPr>
   </p:defaultTextStyle>
+  <p:extLst>
+    <p:ext uri="{EFAFB233-063F-42B5-8137-9DF3F51BA10A}">
+      <p15:sldGuideLst xmlns:p15="http://schemas.microsoft.com/office/powerpoint/2012/main"/>
+    </p:ext>
+  </p:extLst>
 </p:presentation>
 </file>
 
@@ -365,7 +370,7 @@
           <a:p>
             <a:fld id="{4C870BA3-8C99-4885-9116-D5C1F7B5A430}" type="datetimeFigureOut">
               <a:rPr lang="en-US" smtClean="0"/>
-              <a:t>10/19/2026</a:t>
+              <a:t>10/21/2026</a:t>
             </a:fld>
             <a:endParaRPr lang="en-US"/>
           </a:p>
@@ -1259,7 +1264,7 @@
           <a:p>
             <a:fld id="{C509D815-375B-4E25-982C-DE08947284A2}" type="datetimeFigureOut">
               <a:rPr lang="en-US" smtClean="0"/>
-              <a:t>10/19/2026</a:t>
+              <a:t>10/21/2026</a:t>
             </a:fld>
             <a:endParaRPr lang="en-US"/>
           </a:p>
@@ -1457,7 +1462,7 @@
           <a:p>
             <a:fld id="{C509D815-375B-4E25-982C-DE08947284A2}" type="datetimeFigureOut">
               <a:rPr lang="en-US" smtClean="0"/>
-              <a:t>10/19/2026</a:t>
+              <a:t>10/21/2026</a:t>
             </a:fld>
             <a:endParaRPr lang="en-US"/>
           </a:p>
@@ -1665,7 +1670,7 @@
           <a:p>
             <a:fld id="{C509D815-375B-4E25-982C-DE08947284A2}" type="datetimeFigureOut">
               <a:rPr lang="en-US" smtClean="0"/>
-              <a:t>10/19/2026</a:t>
+              <a:t>10/21/2026</a:t>
             </a:fld>
             <a:endParaRPr lang="en-US"/>
           </a:p>
@@ -5667,7 +5672,7 @@
           <a:p>
             <a:fld id="{C509D815-375B-4E25-982C-DE08947284A2}" type="datetimeFigureOut">
               <a:rPr lang="en-US" smtClean="0"/>
-              <a:t>10/19/2026</a:t>
+              <a:t>10/21/2026</a:t>
             </a:fld>
             <a:endParaRPr lang="en-US"/>
           </a:p>
@@ -17447,7 +17452,7 @@
           <a:p>
             <a:fld id="{C509D815-375B-4E25-982C-DE08947284A2}" type="datetimeFigureOut">
               <a:rPr lang="en-US" smtClean="0"/>
-              <a:t>10/19/2026</a:t>
+              <a:t>10/21/2026</a:t>
             </a:fld>
             <a:endParaRPr lang="en-US"/>
           </a:p>
@@ -22241,7 +22246,7 @@
           <a:p>
             <a:fld id="{5BCAD085-E8A6-8845-BD4E-CB4CCA059FC4}" type="datetimeFigureOut">
               <a:rPr lang="en-US" smtClean="0"/>
-              <a:t>10/19/2026</a:t>
+              <a:t>10/21/2026</a:t>
             </a:fld>
             <a:endParaRPr lang="en-US"/>
           </a:p>
@@ -23773,7 +23778,7 @@
           <a:p>
             <a:fld id="{C509D815-375B-4E25-982C-DE08947284A2}" type="datetimeFigureOut">
               <a:rPr lang="en-US" smtClean="0"/>
-              <a:t>10/19/2026</a:t>
+              <a:t>10/21/2026</a:t>
             </a:fld>
             <a:endParaRPr lang="en-US"/>
           </a:p>
@@ -35369,7 +35374,7 @@
           <a:p>
             <a:fld id="{C509D815-375B-4E25-982C-DE08947284A2}" type="datetimeFigureOut">
               <a:rPr lang="en-US" smtClean="0"/>
-              <a:t>10/19/2026</a:t>
+              <a:t>10/21/2026</a:t>
             </a:fld>
             <a:endParaRPr lang="en-US"/>
           </a:p>
@@ -35510,7 +35515,7 @@
           <a:p>
             <a:fld id="{C509D815-375B-4E25-982C-DE08947284A2}" type="datetimeFigureOut">
               <a:rPr lang="en-US" smtClean="0"/>
-              <a:t>10/19/2026</a:t>
+              <a:t>10/21/2026</a:t>
             </a:fld>
             <a:endParaRPr lang="en-US"/>
           </a:p>
@@ -35623,7 +35628,7 @@
           <a:p>
             <a:fld id="{C509D815-375B-4E25-982C-DE08947284A2}" type="datetimeFigureOut">
               <a:rPr lang="en-US" smtClean="0"/>
-              <a:t>10/19/2026</a:t>
+              <a:t>10/21/2026</a:t>
             </a:fld>
             <a:endParaRPr lang="en-US"/>
           </a:p>
@@ -35934,7 +35939,7 @@
           <a:p>
             <a:fld id="{C509D815-375B-4E25-982C-DE08947284A2}" type="datetimeFigureOut">
               <a:rPr lang="en-US" smtClean="0"/>
-              <a:t>10/19/2026</a:t>
+              <a:t>10/21/2026</a:t>
             </a:fld>
             <a:endParaRPr lang="en-US"/>
           </a:p>
@@ -36222,7 +36227,7 @@
           <a:p>
             <a:fld id="{C509D815-375B-4E25-982C-DE08947284A2}" type="datetimeFigureOut">
               <a:rPr lang="en-US" smtClean="0"/>
-              <a:t>10/19/2026</a:t>
+              <a:t>10/21/2026</a:t>
             </a:fld>
             <a:endParaRPr lang="en-US"/>
           </a:p>
@@ -36463,7 +36468,7 @@
           <a:p>
             <a:fld id="{C509D815-375B-4E25-982C-DE08947284A2}" type="datetimeFigureOut">
               <a:rPr lang="en-US" smtClean="0"/>
-              <a:t>10/19/2026</a:t>
+              <a:t>10/21/2026</a:t>
             </a:fld>
             <a:endParaRPr lang="en-US"/>
           </a:p>
@@ -41440,7 +41445,7 @@
         </p:spPr>
         <p:txBody>
           <a:bodyPr>
-            <a:normAutofit fontScale="92500" lnSpcReduction="10000"/>
+            <a:normAutofit fontScale="92500" lnSpcReduction="20000"/>
           </a:bodyPr>
           <a:lstStyle/>
           <a:p>
@@ -41470,8 +41475,32 @@
               <a:buChar char="•"/>
             </a:pPr>
             <a:r>
-              <a:rPr lang="en-US" dirty="0"/>
-              <a:t>Typed text disappears when someone starts typing, goes back to re-read the moment, and returns. Save the draft so it persists until they submit.</a:t>
+              <a:rPr lang="en-IN" dirty="0"/>
+              <a:t>On the brainstorm activity, let's do a single response. </a:t>
+            </a:r>
+          </a:p>
+          <a:p>
+            <a:pPr marL="342900" indent="-342900" algn="l">
+              <a:buFont typeface="Arial" panose="020B0604020202020204" pitchFamily="34" charset="0"/>
+              <a:buChar char="•"/>
+            </a:pPr>
+            <a:r>
+              <a:rPr lang="en-IN" dirty="0"/>
+              <a:t>It should stay in the box even after submission.</a:t>
+            </a:r>
+          </a:p>
+          <a:p>
+            <a:pPr marL="342900" indent="-342900" algn="l">
+              <a:buFont typeface="Arial" panose="020B0604020202020204" pitchFamily="34" charset="0"/>
+              <a:buChar char="•"/>
+            </a:pPr>
+            <a:r>
+              <a:rPr lang="en-IN"/>
+              <a:t>Keep </a:t>
+            </a:r>
+            <a:r>
+              <a:rPr lang="en-IN" dirty="0"/>
+              <a:t>the text box on the same page as the prompt. </a:t>
             </a:r>
           </a:p>
           <a:p>
@@ -41534,10 +41563,9 @@
               <a:buChar char="•"/>
             </a:pPr>
             <a:r>
-              <a:rPr lang="en-US"/>
-              <a:t>Rename  Moment 4 to DO NOT USE</a:t>
+              <a:rPr lang="en-US" dirty="0"/>
+              <a:t>Remove Moment 4 – from GD / Fac / reporter</a:t>
             </a:r>
-            <a:endParaRPr lang="en-US" dirty="0"/>
           </a:p>
         </p:txBody>
       </p:sp>

</xml_diff>

<commit_message>
Updated status in Consultant feedback document
</commit_message>
<xml_diff>
--- a/_dev/Feedback/Consultant/19-Oct/10_19_2026_Update_For_Digital_Simulation.pptx
+++ b/_dev/Feedback/Consultant/19-Oct/10_19_2026_Update_For_Digital_Simulation.pptx
@@ -40246,8 +40246,8 @@
         </p:nvSpPr>
         <p:spPr>
           <a:xfrm>
-            <a:off x="5029201" y="729574"/>
-            <a:ext cx="3842426" cy="535022"/>
+            <a:off x="8414658" y="352737"/>
+            <a:ext cx="2950028" cy="576712"/>
           </a:xfrm>
           <a:prstGeom prst="rect">
             <a:avLst/>
@@ -40281,22 +40281,13 @@
           <a:bodyPr rtlCol="0" anchor="ctr"/>
           <a:lstStyle/>
           <a:p>
-            <a:pPr algn="ctr"/>
             <a:r>
-              <a:rPr lang="en-IN" dirty="0">
+              <a:rPr lang="en-IN" b="1" dirty="0">
                 <a:solidFill>
                   <a:sysClr val="windowText" lastClr="000000"/>
                 </a:solidFill>
               </a:rPr>
-              <a:t>Digital (21</a:t>
-            </a:r>
-            <a:r>
-              <a:rPr lang="en-IN" baseline="30000" dirty="0">
-                <a:solidFill>
-                  <a:sysClr val="windowText" lastClr="000000"/>
-                </a:solidFill>
-              </a:rPr>
-              <a:t>st</a:t>
+              <a:t>Digital (21-Oct):</a:t>
             </a:r>
             <a:r>
               <a:rPr lang="en-IN" dirty="0">
@@ -40304,7 +40295,7 @@
                   <a:sysClr val="windowText" lastClr="000000"/>
                 </a:solidFill>
               </a:rPr>
-              <a:t> Oct) - DONE</a:t>
+              <a:t> Done</a:t>
             </a:r>
           </a:p>
         </p:txBody>
@@ -40475,8 +40466,8 @@
         </p:nvSpPr>
         <p:spPr>
           <a:xfrm>
-            <a:off x="4212078" y="1021403"/>
-            <a:ext cx="6313250" cy="1303507"/>
+            <a:off x="3362992" y="121921"/>
+            <a:ext cx="8045236" cy="1173480"/>
           </a:xfrm>
           <a:prstGeom prst="rect">
             <a:avLst/>
@@ -40518,22 +40509,13 @@
             </a:endParaRPr>
           </a:p>
           <a:p>
-            <a:pPr algn="ctr"/>
             <a:r>
-              <a:rPr lang="en-IN" dirty="0">
+              <a:rPr lang="en-IN" b="1" dirty="0">
                 <a:solidFill>
                   <a:sysClr val="windowText" lastClr="000000"/>
                 </a:solidFill>
               </a:rPr>
-              <a:t>Digital (21</a:t>
-            </a:r>
-            <a:r>
-              <a:rPr lang="en-IN" baseline="30000" dirty="0">
-                <a:solidFill>
-                  <a:sysClr val="windowText" lastClr="000000"/>
-                </a:solidFill>
-              </a:rPr>
-              <a:t>st</a:t>
+              <a:t>Digital (21-Oct): </a:t>
             </a:r>
             <a:r>
               <a:rPr lang="en-IN" dirty="0">
@@ -40541,7 +40523,7 @@
                   <a:sysClr val="windowText" lastClr="000000"/>
                 </a:solidFill>
               </a:rPr>
-              <a:t> Oct) – DONE</a:t>
+              <a:t>Done</a:t>
             </a:r>
             <a:br>
               <a:rPr lang="en-IN" dirty="0">
@@ -40556,7 +40538,7 @@
                   <a:sysClr val="windowText" lastClr="000000"/>
                 </a:solidFill>
               </a:rPr>
-              <a:t>Point 2 – We confirm that the simulation starts with the Welcome =&gt; Assign Base Values=&gt; Team Name =&gt; Case Study and then Moments</a:t>
+              <a:t>Confirming that the simulation starts with the Welcome =&gt; Assign Base Values=&gt; Team Name =&gt; Case Study and then Moments</a:t>
             </a:r>
             <a:br>
               <a:rPr lang="en-IN" dirty="0">
@@ -40777,10 +40759,10 @@
       </p:sp>
       <p:sp>
         <p:nvSpPr>
-          <p:cNvPr id="5" name="Rectangle 4">
+          <p:cNvPr id="6" name="Rectangle 5">
             <a:extLst>
               <a:ext uri="{FF2B5EF4-FFF2-40B4-BE49-F238E27FC236}">
-                <a16:creationId xmlns:a16="http://schemas.microsoft.com/office/drawing/2014/main" id="{D11C66BF-D9A0-2C39-9E6E-81CDAA792949}"/>
+                <a16:creationId xmlns:a16="http://schemas.microsoft.com/office/drawing/2014/main" id="{442DF406-4E08-CD13-1CA8-6D474B81763C}"/>
               </a:ext>
             </a:extLst>
           </p:cNvPr>
@@ -40789,8 +40771,8 @@
         </p:nvSpPr>
         <p:spPr>
           <a:xfrm>
-            <a:off x="5029201" y="729574"/>
-            <a:ext cx="3842426" cy="535022"/>
+            <a:off x="8414658" y="352737"/>
+            <a:ext cx="2950028" cy="576712"/>
           </a:xfrm>
           <a:prstGeom prst="rect">
             <a:avLst/>
@@ -40824,22 +40806,13 @@
           <a:bodyPr rtlCol="0" anchor="ctr"/>
           <a:lstStyle/>
           <a:p>
-            <a:pPr algn="ctr"/>
             <a:r>
-              <a:rPr lang="en-IN" dirty="0">
+              <a:rPr lang="en-IN" b="1" dirty="0">
                 <a:solidFill>
                   <a:sysClr val="windowText" lastClr="000000"/>
                 </a:solidFill>
               </a:rPr>
-              <a:t>Digital (21</a:t>
-            </a:r>
-            <a:r>
-              <a:rPr lang="en-IN" baseline="30000" dirty="0">
-                <a:solidFill>
-                  <a:sysClr val="windowText" lastClr="000000"/>
-                </a:solidFill>
-              </a:rPr>
-              <a:t>st</a:t>
+              <a:t>Digital (21-Oct):</a:t>
             </a:r>
             <a:r>
               <a:rPr lang="en-IN" dirty="0">
@@ -40847,7 +40820,7 @@
                   <a:sysClr val="windowText" lastClr="000000"/>
                 </a:solidFill>
               </a:rPr>
-              <a:t> Oct) - DONE</a:t>
+              <a:t> Done</a:t>
             </a:r>
           </a:p>
         </p:txBody>
@@ -41034,10 +41007,10 @@
       </p:sp>
       <p:sp>
         <p:nvSpPr>
-          <p:cNvPr id="5" name="Rectangle 4">
+          <p:cNvPr id="6" name="Rectangle 5">
             <a:extLst>
               <a:ext uri="{FF2B5EF4-FFF2-40B4-BE49-F238E27FC236}">
-                <a16:creationId xmlns:a16="http://schemas.microsoft.com/office/drawing/2014/main" id="{C0FB16F0-7EBF-A951-8A72-22E508EAD5E5}"/>
+                <a16:creationId xmlns:a16="http://schemas.microsoft.com/office/drawing/2014/main" id="{B57C2C1C-F351-4F2C-912B-CD9FD2C87AA7}"/>
               </a:ext>
             </a:extLst>
           </p:cNvPr>
@@ -41046,8 +41019,8 @@
         </p:nvSpPr>
         <p:spPr>
           <a:xfrm>
-            <a:off x="5029201" y="729574"/>
-            <a:ext cx="3842426" cy="535022"/>
+            <a:off x="8414658" y="352737"/>
+            <a:ext cx="2950028" cy="576712"/>
           </a:xfrm>
           <a:prstGeom prst="rect">
             <a:avLst/>
@@ -41081,22 +41054,13 @@
           <a:bodyPr rtlCol="0" anchor="ctr"/>
           <a:lstStyle/>
           <a:p>
-            <a:pPr algn="ctr"/>
             <a:r>
-              <a:rPr lang="en-IN" dirty="0">
+              <a:rPr lang="en-IN" b="1" dirty="0">
                 <a:solidFill>
                   <a:sysClr val="windowText" lastClr="000000"/>
                 </a:solidFill>
               </a:rPr>
-              <a:t>Digital (21</a:t>
-            </a:r>
-            <a:r>
-              <a:rPr lang="en-IN" baseline="30000" dirty="0">
-                <a:solidFill>
-                  <a:sysClr val="windowText" lastClr="000000"/>
-                </a:solidFill>
-              </a:rPr>
-              <a:t>st</a:t>
+              <a:t>Digital (21-Oct):</a:t>
             </a:r>
             <a:r>
               <a:rPr lang="en-IN" dirty="0">
@@ -41104,7 +41068,7 @@
                   <a:sysClr val="windowText" lastClr="000000"/>
                 </a:solidFill>
               </a:rPr>
-              <a:t> Oct) - DONE</a:t>
+              <a:t> Done</a:t>
             </a:r>
           </a:p>
         </p:txBody>
@@ -41300,10 +41264,10 @@
       </p:sp>
       <p:sp>
         <p:nvSpPr>
-          <p:cNvPr id="5" name="Rectangle 4">
+          <p:cNvPr id="6" name="Rectangle 5">
             <a:extLst>
               <a:ext uri="{FF2B5EF4-FFF2-40B4-BE49-F238E27FC236}">
-                <a16:creationId xmlns:a16="http://schemas.microsoft.com/office/drawing/2014/main" id="{CE4BE64D-61B2-28C8-06D2-4ECE74169872}"/>
+                <a16:creationId xmlns:a16="http://schemas.microsoft.com/office/drawing/2014/main" id="{9B7246F6-D2F0-1BC8-67CF-C64F8AC09842}"/>
               </a:ext>
             </a:extLst>
           </p:cNvPr>
@@ -41312,8 +41276,8 @@
         </p:nvSpPr>
         <p:spPr>
           <a:xfrm>
-            <a:off x="5029201" y="729574"/>
-            <a:ext cx="3842426" cy="535022"/>
+            <a:off x="8414658" y="352737"/>
+            <a:ext cx="2950028" cy="576712"/>
           </a:xfrm>
           <a:prstGeom prst="rect">
             <a:avLst/>
@@ -41347,22 +41311,13 @@
           <a:bodyPr rtlCol="0" anchor="ctr"/>
           <a:lstStyle/>
           <a:p>
-            <a:pPr algn="ctr"/>
             <a:r>
-              <a:rPr lang="en-IN" dirty="0">
+              <a:rPr lang="en-IN" b="1" dirty="0">
                 <a:solidFill>
                   <a:sysClr val="windowText" lastClr="000000"/>
                 </a:solidFill>
               </a:rPr>
-              <a:t>Digital (21</a:t>
-            </a:r>
-            <a:r>
-              <a:rPr lang="en-IN" baseline="30000" dirty="0">
-                <a:solidFill>
-                  <a:sysClr val="windowText" lastClr="000000"/>
-                </a:solidFill>
-              </a:rPr>
-              <a:t>st</a:t>
+              <a:t>Digital (21-Oct):</a:t>
             </a:r>
             <a:r>
               <a:rPr lang="en-IN" dirty="0">
@@ -41370,7 +41325,7 @@
                   <a:sysClr val="windowText" lastClr="000000"/>
                 </a:solidFill>
               </a:rPr>
-              <a:t> Oct) - DONE</a:t>
+              <a:t> Done</a:t>
             </a:r>
           </a:p>
         </p:txBody>
@@ -41544,10 +41499,10 @@
       </p:sp>
       <p:sp>
         <p:nvSpPr>
-          <p:cNvPr id="5" name="Rectangle 4">
+          <p:cNvPr id="6" name="Rectangle 5">
             <a:extLst>
               <a:ext uri="{FF2B5EF4-FFF2-40B4-BE49-F238E27FC236}">
-                <a16:creationId xmlns:a16="http://schemas.microsoft.com/office/drawing/2014/main" id="{B804FE3F-6E3B-A18D-8407-4C4A32C149A9}"/>
+                <a16:creationId xmlns:a16="http://schemas.microsoft.com/office/drawing/2014/main" id="{87209669-2EB3-3D4E-0EBE-42C7ABA67F55}"/>
               </a:ext>
             </a:extLst>
           </p:cNvPr>
@@ -41556,8 +41511,8 @@
         </p:nvSpPr>
         <p:spPr>
           <a:xfrm>
-            <a:off x="5029201" y="729574"/>
-            <a:ext cx="3842426" cy="535022"/>
+            <a:off x="8414658" y="352737"/>
+            <a:ext cx="2950028" cy="576712"/>
           </a:xfrm>
           <a:prstGeom prst="rect">
             <a:avLst/>
@@ -41591,22 +41546,13 @@
           <a:bodyPr rtlCol="0" anchor="ctr"/>
           <a:lstStyle/>
           <a:p>
-            <a:pPr algn="ctr"/>
             <a:r>
-              <a:rPr lang="en-IN" dirty="0">
+              <a:rPr lang="en-IN" b="1" dirty="0">
                 <a:solidFill>
                   <a:sysClr val="windowText" lastClr="000000"/>
                 </a:solidFill>
               </a:rPr>
-              <a:t>Digital (21</a:t>
-            </a:r>
-            <a:r>
-              <a:rPr lang="en-IN" baseline="30000" dirty="0">
-                <a:solidFill>
-                  <a:sysClr val="windowText" lastClr="000000"/>
-                </a:solidFill>
-              </a:rPr>
-              <a:t>st</a:t>
+              <a:t>Digital (21-Oct):</a:t>
             </a:r>
             <a:r>
               <a:rPr lang="en-IN" dirty="0">
@@ -41614,7 +41560,7 @@
                   <a:sysClr val="windowText" lastClr="000000"/>
                 </a:solidFill>
               </a:rPr>
-              <a:t> Oct) - DONE</a:t>
+              <a:t> Done</a:t>
             </a:r>
           </a:p>
         </p:txBody>
@@ -41719,8 +41665,8 @@
         </p:nvSpPr>
         <p:spPr>
           <a:xfrm>
-            <a:off x="3608962" y="2315183"/>
-            <a:ext cx="4426085" cy="836579"/>
+            <a:off x="1910791" y="2424041"/>
+            <a:ext cx="7810152" cy="1004960"/>
           </a:xfrm>
           <a:prstGeom prst="rect">
             <a:avLst/>
@@ -41749,22 +41695,13 @@
           <a:bodyPr rtlCol="0" anchor="ctr"/>
           <a:lstStyle/>
           <a:p>
-            <a:pPr algn="ctr"/>
             <a:r>
-              <a:rPr lang="en-IN" dirty="0">
+              <a:rPr lang="en-IN" b="1" dirty="0">
                 <a:solidFill>
                   <a:schemeClr val="tx1"/>
                 </a:solidFill>
               </a:rPr>
-              <a:t>Digital (21</a:t>
-            </a:r>
-            <a:r>
-              <a:rPr lang="en-IN" baseline="30000" dirty="0">
-                <a:solidFill>
-                  <a:schemeClr val="tx1"/>
-                </a:solidFill>
-              </a:rPr>
-              <a:t>st</a:t>
+              <a:t>Digital (21-Oct): </a:t>
             </a:r>
             <a:r>
               <a:rPr lang="en-IN" dirty="0">
@@ -41772,7 +41709,17 @@
                   <a:schemeClr val="tx1"/>
                 </a:solidFill>
               </a:rPr>
-              <a:t> Oct): Could not replicate this issue.</a:t>
+              <a:t>We were unable to replicate this issue. </a:t>
+            </a:r>
+          </a:p>
+          <a:p>
+            <a:r>
+              <a:rPr lang="en-IN" dirty="0">
+                <a:solidFill>
+                  <a:schemeClr val="tx1"/>
+                </a:solidFill>
+              </a:rPr>
+              <a:t>As mentioned earlier, it may have occurred because updates were being made to the sim while the team was testing it.</a:t>
             </a:r>
           </a:p>
         </p:txBody>
@@ -41956,10 +41903,10 @@
       </p:sp>
       <p:sp>
         <p:nvSpPr>
-          <p:cNvPr id="5" name="Rectangle 4">
+          <p:cNvPr id="6" name="Rectangle 5">
             <a:extLst>
               <a:ext uri="{FF2B5EF4-FFF2-40B4-BE49-F238E27FC236}">
-                <a16:creationId xmlns:a16="http://schemas.microsoft.com/office/drawing/2014/main" id="{2F312111-EAB3-028A-18EB-223030711C7C}"/>
+                <a16:creationId xmlns:a16="http://schemas.microsoft.com/office/drawing/2014/main" id="{D77220C1-F0F0-0270-3982-FF1A0340D381}"/>
               </a:ext>
             </a:extLst>
           </p:cNvPr>
@@ -41968,8 +41915,8 @@
         </p:nvSpPr>
         <p:spPr>
           <a:xfrm>
-            <a:off x="5029201" y="729574"/>
-            <a:ext cx="3842426" cy="535022"/>
+            <a:off x="8414658" y="352737"/>
+            <a:ext cx="2950028" cy="576712"/>
           </a:xfrm>
           <a:prstGeom prst="rect">
             <a:avLst/>
@@ -42003,22 +41950,13 @@
           <a:bodyPr rtlCol="0" anchor="ctr"/>
           <a:lstStyle/>
           <a:p>
-            <a:pPr algn="ctr"/>
             <a:r>
-              <a:rPr lang="en-IN" dirty="0">
+              <a:rPr lang="en-IN" b="1" dirty="0">
                 <a:solidFill>
                   <a:sysClr val="windowText" lastClr="000000"/>
                 </a:solidFill>
               </a:rPr>
-              <a:t>Digital (21</a:t>
-            </a:r>
-            <a:r>
-              <a:rPr lang="en-IN" baseline="30000" dirty="0">
-                <a:solidFill>
-                  <a:sysClr val="windowText" lastClr="000000"/>
-                </a:solidFill>
-              </a:rPr>
-              <a:t>st</a:t>
+              <a:t>Digital (21-Oct):</a:t>
             </a:r>
             <a:r>
               <a:rPr lang="en-IN" dirty="0">
@@ -42026,7 +41964,7 @@
                   <a:sysClr val="windowText" lastClr="000000"/>
                 </a:solidFill>
               </a:rPr>
-              <a:t> Oct) - DONE</a:t>
+              <a:t> Done</a:t>
             </a:r>
           </a:p>
         </p:txBody>
@@ -42213,10 +42151,10 @@
       </p:sp>
       <p:sp>
         <p:nvSpPr>
-          <p:cNvPr id="4" name="Rectangle 3">
+          <p:cNvPr id="5" name="Rectangle 4">
             <a:extLst>
               <a:ext uri="{FF2B5EF4-FFF2-40B4-BE49-F238E27FC236}">
-                <a16:creationId xmlns:a16="http://schemas.microsoft.com/office/drawing/2014/main" id="{EFAA6C26-5E42-AD02-4521-2B7B7851F200}"/>
+                <a16:creationId xmlns:a16="http://schemas.microsoft.com/office/drawing/2014/main" id="{449DBBFA-5282-B4FC-8F70-1941D9028DED}"/>
               </a:ext>
             </a:extLst>
           </p:cNvPr>
@@ -42225,8 +42163,8 @@
         </p:nvSpPr>
         <p:spPr>
           <a:xfrm>
-            <a:off x="5029201" y="452945"/>
-            <a:ext cx="3842426" cy="535022"/>
+            <a:off x="8414658" y="352737"/>
+            <a:ext cx="2950028" cy="576712"/>
           </a:xfrm>
           <a:prstGeom prst="rect">
             <a:avLst/>
@@ -42260,22 +42198,13 @@
           <a:bodyPr rtlCol="0" anchor="ctr"/>
           <a:lstStyle/>
           <a:p>
-            <a:pPr algn="ctr"/>
             <a:r>
-              <a:rPr lang="en-IN" dirty="0">
+              <a:rPr lang="en-IN" b="1" dirty="0">
                 <a:solidFill>
                   <a:sysClr val="windowText" lastClr="000000"/>
                 </a:solidFill>
               </a:rPr>
-              <a:t>Digital (21</a:t>
-            </a:r>
-            <a:r>
-              <a:rPr lang="en-IN" baseline="30000" dirty="0">
-                <a:solidFill>
-                  <a:sysClr val="windowText" lastClr="000000"/>
-                </a:solidFill>
-              </a:rPr>
-              <a:t>st</a:t>
+              <a:t>Digital (21-Oct):</a:t>
             </a:r>
             <a:r>
               <a:rPr lang="en-IN" dirty="0">
@@ -42283,7 +42212,7 @@
                   <a:sysClr val="windowText" lastClr="000000"/>
                 </a:solidFill>
               </a:rPr>
-              <a:t> Oct) - DONE</a:t>
+              <a:t> Done</a:t>
             </a:r>
           </a:p>
         </p:txBody>

</xml_diff>